<commit_message>
Give each slide-2 question its stake
Each column now runs question, detail, then a one-line italic stake — what
actually turns on the answer. The detail paragraphs were trimmed to make room,
and the band moved up slightly to fit the third tier.

The stakes are the part that makes these worth someone's time: without an
agreed benchmark the dashboard can publish composition but not a judgment
about it; the social-factors answer decides what the rest of the schema budget
buys; a false "not reported" makes the central claim unsafe to state; and the
closing item asks which cut of the record to build first.

Co-Authored-By: Claude Opus 5 <noreply@anthropic.com>
Claude-Session: https://claude.ai/code/session_01EiKQ8q6cKC5FEpVgvE6GeX
</commit_message>
<xml_diff>
--- a/slides/Presentation_for_Anthropic_Healthcare_filled.pptx
+++ b/slides/Presentation_for_Anthropic_Healthcare_filled.pptx
@@ -3202,7 +3202,7 @@
         </p:nvSpPr>
         <p:spPr>
           <a:xfrm>
-            <a:off x="320040" y="3291840"/>
+            <a:off x="320040" y="3255264"/>
             <a:ext cx="8503920" cy="11430"/>
           </a:xfrm>
           <a:prstGeom prst="rect">
@@ -3246,7 +3246,7 @@
         </p:nvSpPr>
         <p:spPr>
           <a:xfrm>
-            <a:off x="320040" y="3364992"/>
+            <a:off x="320040" y="3310128"/>
             <a:ext cx="6858000" cy="237744"/>
           </a:xfrm>
           <a:prstGeom prst="rect">
@@ -3280,7 +3280,7 @@
         </p:nvSpPr>
         <p:spPr>
           <a:xfrm>
-            <a:off x="320040" y="3621024"/>
+            <a:off x="320040" y="3547872"/>
             <a:ext cx="2011680" cy="109728"/>
           </a:xfrm>
           <a:prstGeom prst="rect">
@@ -3314,7 +3314,7 @@
         </p:nvSpPr>
         <p:spPr>
           <a:xfrm>
-            <a:off x="320040" y="3739896"/>
+            <a:off x="320040" y="3657600"/>
             <a:ext cx="146304" cy="118872"/>
           </a:xfrm>
           <a:prstGeom prst="rect">
@@ -3348,7 +3348,7 @@
         </p:nvSpPr>
         <p:spPr>
           <a:xfrm>
-            <a:off x="466344" y="3739896"/>
+            <a:off x="466344" y="3657600"/>
             <a:ext cx="1865376" cy="237744"/>
           </a:xfrm>
           <a:prstGeom prst="rect">
@@ -3387,8 +3387,8 @@
         </p:nvSpPr>
         <p:spPr>
           <a:xfrm>
-            <a:off x="466344" y="4005072"/>
-            <a:ext cx="1865376" cy="731520"/>
+            <a:off x="466344" y="3913632"/>
+            <a:ext cx="1865376" cy="566928"/>
           </a:xfrm>
           <a:prstGeom prst="rect">
             <a:avLst/>
@@ -3413,7 +3413,7 @@
                 </a:solidFill>
                 <a:latin typeface="Century Schoolbook"/>
               </a:rPr>
-              <a:t>We can report that a validation cohort was 84% White. We cannot say whether that is a problem. The benchmark could be the census, the condition’s own epidemiology, or the deploying hospital’s patient panel — and they disagree. Without an agreed denominator the dashboard describes composition but cannot flag risk.</a:t>
+              <a:t>We can report that a validation cohort was 84% White. We cannot say whether that is a problem. The census, the condition’s own epidemiology and the deploying hospital’s panel all give different answers.</a:t>
             </a:r>
           </a:p>
         </p:txBody>
@@ -3426,7 +3426,46 @@
         </p:nvSpPr>
         <p:spPr>
           <a:xfrm>
-            <a:off x="2484120" y="3621024"/>
+            <a:off x="466344" y="4517136"/>
+            <a:ext cx="1865376" cy="256032"/>
+          </a:xfrm>
+          <a:prstGeom prst="rect">
+            <a:avLst/>
+          </a:prstGeom>
+          <a:noFill/>
+        </p:spPr>
+        <p:txBody>
+          <a:bodyPr wrap="square" lIns="0" rIns="0" tIns="0" bIns="0">
+            <a:spAutoFit/>
+          </a:bodyPr>
+          <a:lstStyle/>
+          <a:p>
+            <a:pPr>
+              <a:lnSpc>
+                <a:spcPct val="98000"/>
+              </a:lnSpc>
+            </a:pPr>
+            <a:r>
+              <a:rPr sz="640" b="0" i="1">
+                <a:solidFill>
+                  <a:srgbClr val="111827"/>
+                </a:solidFill>
+                <a:latin typeface="Century Schoolbook"/>
+              </a:rPr>
+              <a:t>Until this is settled we can publish composition, but not a judgment about it.</a:t>
+            </a:r>
+          </a:p>
+        </p:txBody>
+      </p:sp>
+      <p:sp>
+        <p:nvSpPr>
+          <p:cNvPr id="47" name="TextBox 46"/>
+          <p:cNvSpPr txBox="1"/>
+          <p:nvPr/>
+        </p:nvSpPr>
+        <p:spPr>
+          <a:xfrm>
+            <a:off x="2484120" y="3547872"/>
             <a:ext cx="2011680" cy="109728"/>
           </a:xfrm>
           <a:prstGeom prst="rect">
@@ -3454,13 +3493,13 @@
       </p:sp>
       <p:sp>
         <p:nvSpPr>
-          <p:cNvPr id="47" name="TextBox 46"/>
-          <p:cNvSpPr txBox="1"/>
-          <p:nvPr/>
-        </p:nvSpPr>
-        <p:spPr>
-          <a:xfrm>
-            <a:off x="2484120" y="3739896"/>
+          <p:cNvPr id="48" name="TextBox 47"/>
+          <p:cNvSpPr txBox="1"/>
+          <p:nvPr/>
+        </p:nvSpPr>
+        <p:spPr>
+          <a:xfrm>
+            <a:off x="2484120" y="3657600"/>
             <a:ext cx="146304" cy="118872"/>
           </a:xfrm>
           <a:prstGeom prst="rect">
@@ -3488,13 +3527,13 @@
       </p:sp>
       <p:sp>
         <p:nvSpPr>
-          <p:cNvPr id="48" name="TextBox 47"/>
-          <p:cNvSpPr txBox="1"/>
-          <p:nvPr/>
-        </p:nvSpPr>
-        <p:spPr>
-          <a:xfrm>
-            <a:off x="2630424" y="3739896"/>
+          <p:cNvPr id="49" name="TextBox 48"/>
+          <p:cNvSpPr txBox="1"/>
+          <p:nvPr/>
+        </p:nvSpPr>
+        <p:spPr>
+          <a:xfrm>
+            <a:off x="2630424" y="3657600"/>
             <a:ext cx="1865376" cy="237744"/>
           </a:xfrm>
           <a:prstGeom prst="rect">
@@ -3527,14 +3566,14 @@
       </p:sp>
       <p:sp>
         <p:nvSpPr>
-          <p:cNvPr id="49" name="TextBox 48"/>
-          <p:cNvSpPr txBox="1"/>
-          <p:nvPr/>
-        </p:nvSpPr>
-        <p:spPr>
-          <a:xfrm>
-            <a:off x="2630424" y="4005072"/>
-            <a:ext cx="1865376" cy="731520"/>
+          <p:cNvPr id="50" name="TextBox 49"/>
+          <p:cNvSpPr txBox="1"/>
+          <p:nvPr/>
+        </p:nvSpPr>
+        <p:spPr>
+          <a:xfrm>
+            <a:off x="2630424" y="3913632"/>
+            <a:ext cx="1865376" cy="566928"/>
           </a:xfrm>
           <a:prstGeom prst="rect">
             <a:avLst/>
@@ -3559,20 +3598,59 @@
                 </a:solidFill>
                 <a:latin typeface="Century Schoolbook"/>
               </a:rPr>
-              <a:t>The schema reserves fields for income, education, insurance and neighborhood, but each one costs tokens and curator review. Which of these would actually change whether a health system deploys a tool, and which are good to know but not decision-relevant?</a:t>
-            </a:r>
-          </a:p>
-        </p:txBody>
-      </p:sp>
-      <p:sp>
-        <p:nvSpPr>
-          <p:cNvPr id="50" name="TextBox 49"/>
-          <p:cNvSpPr txBox="1"/>
-          <p:nvPr/>
-        </p:nvSpPr>
-        <p:spPr>
-          <a:xfrm>
-            <a:off x="4648200" y="3621024"/>
+              <a:t>The schema reserves fields for income, education, insurance and neighborhood, but each one costs tokens and curator review to keep.</a:t>
+            </a:r>
+          </a:p>
+        </p:txBody>
+      </p:sp>
+      <p:sp>
+        <p:nvSpPr>
+          <p:cNvPr id="51" name="TextBox 50"/>
+          <p:cNvSpPr txBox="1"/>
+          <p:nvPr/>
+        </p:nvSpPr>
+        <p:spPr>
+          <a:xfrm>
+            <a:off x="2630424" y="4517136"/>
+            <a:ext cx="1865376" cy="256032"/>
+          </a:xfrm>
+          <a:prstGeom prst="rect">
+            <a:avLst/>
+          </a:prstGeom>
+          <a:noFill/>
+        </p:spPr>
+        <p:txBody>
+          <a:bodyPr wrap="square" lIns="0" rIns="0" tIns="0" bIns="0">
+            <a:spAutoFit/>
+          </a:bodyPr>
+          <a:lstStyle/>
+          <a:p>
+            <a:pPr>
+              <a:lnSpc>
+                <a:spcPct val="98000"/>
+              </a:lnSpc>
+            </a:pPr>
+            <a:r>
+              <a:rPr sz="640" b="0" i="1">
+                <a:solidFill>
+                  <a:srgbClr val="111827"/>
+                </a:solidFill>
+                <a:latin typeface="Century Schoolbook"/>
+              </a:rPr>
+              <a:t>Your answer decides what the rest of the schema budget buys.</a:t>
+            </a:r>
+          </a:p>
+        </p:txBody>
+      </p:sp>
+      <p:sp>
+        <p:nvSpPr>
+          <p:cNvPr id="52" name="TextBox 51"/>
+          <p:cNvSpPr txBox="1"/>
+          <p:nvPr/>
+        </p:nvSpPr>
+        <p:spPr>
+          <a:xfrm>
+            <a:off x="4648200" y="3547872"/>
             <a:ext cx="2011680" cy="109728"/>
           </a:xfrm>
           <a:prstGeom prst="rect">
@@ -3600,13 +3678,13 @@
       </p:sp>
       <p:sp>
         <p:nvSpPr>
-          <p:cNvPr id="51" name="TextBox 50"/>
-          <p:cNvSpPr txBox="1"/>
-          <p:nvPr/>
-        </p:nvSpPr>
-        <p:spPr>
-          <a:xfrm>
-            <a:off x="4648200" y="3739896"/>
+          <p:cNvPr id="53" name="TextBox 52"/>
+          <p:cNvSpPr txBox="1"/>
+          <p:nvPr/>
+        </p:nvSpPr>
+        <p:spPr>
+          <a:xfrm>
+            <a:off x="4648200" y="3657600"/>
             <a:ext cx="146304" cy="118872"/>
           </a:xfrm>
           <a:prstGeom prst="rect">
@@ -3634,13 +3712,13 @@
       </p:sp>
       <p:sp>
         <p:nvSpPr>
-          <p:cNvPr id="52" name="TextBox 51"/>
-          <p:cNvSpPr txBox="1"/>
-          <p:nvPr/>
-        </p:nvSpPr>
-        <p:spPr>
-          <a:xfrm>
-            <a:off x="4794504" y="3739896"/>
+          <p:cNvPr id="54" name="TextBox 53"/>
+          <p:cNvSpPr txBox="1"/>
+          <p:nvPr/>
+        </p:nvSpPr>
+        <p:spPr>
+          <a:xfrm>
+            <a:off x="4794504" y="3657600"/>
             <a:ext cx="1865376" cy="237744"/>
           </a:xfrm>
           <a:prstGeom prst="rect">
@@ -3673,14 +3751,14 @@
       </p:sp>
       <p:sp>
         <p:nvSpPr>
-          <p:cNvPr id="53" name="TextBox 52"/>
-          <p:cNvSpPr txBox="1"/>
-          <p:nvPr/>
-        </p:nvSpPr>
-        <p:spPr>
-          <a:xfrm>
-            <a:off x="4794504" y="4005072"/>
-            <a:ext cx="1865376" cy="731520"/>
+          <p:cNvPr id="55" name="TextBox 54"/>
+          <p:cNvSpPr txBox="1"/>
+          <p:nvPr/>
+        </p:nvSpPr>
+        <p:spPr>
+          <a:xfrm>
+            <a:off x="4794504" y="3913632"/>
+            <a:ext cx="1865376" cy="566928"/>
           </a:xfrm>
           <a:prstGeom prst="rect">
             <a:avLst/>
@@ -3705,20 +3783,59 @@
                 </a:solidFill>
                 <a:latin typeface="Century Schoolbook"/>
               </a:rPr>
-              <a:t>Our headline finding is what is never reported, so a false “not reported” is the failure that matters most. Quoting evidence before committing a value makes a positive claim auditable, but a silent document and a skipped page look identical in the output. How would you prompt or verify to separate them?</a:t>
-            </a:r>
-          </a:p>
-        </p:txBody>
-      </p:sp>
-      <p:sp>
-        <p:nvSpPr>
-          <p:cNvPr id="54" name="TextBox 53"/>
-          <p:cNvSpPr txBox="1"/>
-          <p:nvPr/>
-        </p:nvSpPr>
-        <p:spPr>
-          <a:xfrm>
-            <a:off x="6812279" y="3621024"/>
+              <a:t>Quoting evidence before committing a value makes a positive claim auditable. But a document that is genuinely silent and a page the model skipped look identical in the output. How would you prompt or verify to tell them apart?</a:t>
+            </a:r>
+          </a:p>
+        </p:txBody>
+      </p:sp>
+      <p:sp>
+        <p:nvSpPr>
+          <p:cNvPr id="56" name="TextBox 55"/>
+          <p:cNvSpPr txBox="1"/>
+          <p:nvPr/>
+        </p:nvSpPr>
+        <p:spPr>
+          <a:xfrm>
+            <a:off x="4794504" y="4517136"/>
+            <a:ext cx="1865376" cy="256032"/>
+          </a:xfrm>
+          <a:prstGeom prst="rect">
+            <a:avLst/>
+          </a:prstGeom>
+          <a:noFill/>
+        </p:spPr>
+        <p:txBody>
+          <a:bodyPr wrap="square" lIns="0" rIns="0" tIns="0" bIns="0">
+            <a:spAutoFit/>
+          </a:bodyPr>
+          <a:lstStyle/>
+          <a:p>
+            <a:pPr>
+              <a:lnSpc>
+                <a:spcPct val="98000"/>
+              </a:lnSpc>
+            </a:pPr>
+            <a:r>
+              <a:rPr sz="640" b="0" i="1">
+                <a:solidFill>
+                  <a:srgbClr val="111827"/>
+                </a:solidFill>
+                <a:latin typeface="Century Schoolbook"/>
+              </a:rPr>
+              <a:t>Get this wrong and the central claim — that demographics are missing — is unsafe to make.</a:t>
+            </a:r>
+          </a:p>
+        </p:txBody>
+      </p:sp>
+      <p:sp>
+        <p:nvSpPr>
+          <p:cNvPr id="57" name="TextBox 56"/>
+          <p:cNvSpPr txBox="1"/>
+          <p:nvPr/>
+        </p:nvSpPr>
+        <p:spPr>
+          <a:xfrm>
+            <a:off x="6812279" y="3547872"/>
             <a:ext cx="2011680" cy="109728"/>
           </a:xfrm>
           <a:prstGeom prst="rect">
@@ -3746,13 +3863,13 @@
       </p:sp>
       <p:sp>
         <p:nvSpPr>
-          <p:cNvPr id="55" name="TextBox 54"/>
-          <p:cNvSpPr txBox="1"/>
-          <p:nvPr/>
-        </p:nvSpPr>
-        <p:spPr>
-          <a:xfrm>
-            <a:off x="6812279" y="3739896"/>
+          <p:cNvPr id="58" name="TextBox 57"/>
+          <p:cNvSpPr txBox="1"/>
+          <p:nvPr/>
+        </p:nvSpPr>
+        <p:spPr>
+          <a:xfrm>
+            <a:off x="6812279" y="3657600"/>
             <a:ext cx="146304" cy="118872"/>
           </a:xfrm>
           <a:prstGeom prst="rect">
@@ -3780,13 +3897,13 @@
       </p:sp>
       <p:sp>
         <p:nvSpPr>
-          <p:cNvPr id="56" name="TextBox 55"/>
-          <p:cNvSpPr txBox="1"/>
-          <p:nvPr/>
-        </p:nvSpPr>
-        <p:spPr>
-          <a:xfrm>
-            <a:off x="6958583" y="3739896"/>
+          <p:cNvPr id="59" name="TextBox 58"/>
+          <p:cNvSpPr txBox="1"/>
+          <p:nvPr/>
+        </p:nvSpPr>
+        <p:spPr>
+          <a:xfrm>
+            <a:off x="6958583" y="3657600"/>
             <a:ext cx="1865376" cy="237744"/>
           </a:xfrm>
           <a:prstGeom prst="rect">
@@ -3819,14 +3936,14 @@
       </p:sp>
       <p:sp>
         <p:nvSpPr>
-          <p:cNvPr id="57" name="TextBox 56"/>
-          <p:cNvSpPr txBox="1"/>
-          <p:nvPr/>
-        </p:nvSpPr>
-        <p:spPr>
-          <a:xfrm>
-            <a:off x="6958583" y="4005072"/>
-            <a:ext cx="1865376" cy="731520"/>
+          <p:cNvPr id="60" name="TextBox 59"/>
+          <p:cNvSpPr txBox="1"/>
+          <p:nvPr/>
+        </p:nvSpPr>
+        <p:spPr>
+          <a:xfrm>
+            <a:off x="6958583" y="3913632"/>
+            <a:ext cx="1865376" cy="566928"/>
           </a:xfrm>
           <a:prstGeom prst="rect">
             <a:avLst/>
@@ -3851,20 +3968,59 @@
                 </a:solidFill>
                 <a:latin typeface="Century Schoolbook"/>
               </a:rPr>
-              <a:t>This becomes a public, evidence-linked record of who was in the validation cohort behind every FDA-authorized AI/ML device, each value traceable to its source page. That is the question health systems raise in procurement and the gap in what 510(k) summaries disclose today. Useful in your healthcare and policy conversations — and if so, in what cut?</a:t>
-            </a:r>
-          </a:p>
-        </p:txBody>
-      </p:sp>
-      <p:sp>
-        <p:nvSpPr>
-          <p:cNvPr id="58" name="TextBox 57"/>
-          <p:cNvSpPr txBox="1"/>
-          <p:nvPr/>
-        </p:nvSpPr>
-        <p:spPr>
-          <a:xfrm>
-            <a:off x="320040" y="4809744"/>
+              <a:t>A public, evidence-linked record of who was in the validation cohort behind every FDA-authorized AI/ML device, each value traceable to its source page — the question health systems raise in procurement, on the gap 510(k) summaries leave open.</a:t>
+            </a:r>
+          </a:p>
+        </p:txBody>
+      </p:sp>
+      <p:sp>
+        <p:nvSpPr>
+          <p:cNvPr id="61" name="TextBox 60"/>
+          <p:cNvSpPr txBox="1"/>
+          <p:nvPr/>
+        </p:nvSpPr>
+        <p:spPr>
+          <a:xfrm>
+            <a:off x="6958583" y="4517136"/>
+            <a:ext cx="1865376" cy="256032"/>
+          </a:xfrm>
+          <a:prstGeom prst="rect">
+            <a:avLst/>
+          </a:prstGeom>
+          <a:noFill/>
+        </p:spPr>
+        <p:txBody>
+          <a:bodyPr wrap="square" lIns="0" rIns="0" tIns="0" bIns="0">
+            <a:spAutoFit/>
+          </a:bodyPr>
+          <a:lstStyle/>
+          <a:p>
+            <a:pPr>
+              <a:lnSpc>
+                <a:spcPct val="98000"/>
+              </a:lnSpc>
+            </a:pPr>
+            <a:r>
+              <a:rPr sz="640" b="0" i="1">
+                <a:solidFill>
+                  <a:srgbClr val="111827"/>
+                </a:solidFill>
+                <a:latin typeface="Century Schoolbook"/>
+              </a:rPr>
+              <a:t>Tells us which cut to build first, and who to build it with.</a:t>
+            </a:r>
+          </a:p>
+        </p:txBody>
+      </p:sp>
+      <p:sp>
+        <p:nvSpPr>
+          <p:cNvPr id="62" name="TextBox 61"/>
+          <p:cNvSpPr txBox="1"/>
+          <p:nvPr/>
+        </p:nvSpPr>
+        <p:spPr>
+          <a:xfrm>
+            <a:off x="320040" y="4846320"/>
             <a:ext cx="8503920" cy="201168"/>
           </a:xfrm>
           <a:prstGeom prst="rect">

</xml_diff>

<commit_message>
Make slide 2's closing item an argument, not a description
The Anthropic-facing column described the artifact and trailed into a
fragment about 510(k) summaries, without saying what their team would
actually do with it.

Rewritten to lead with the problem their customers raise — health systems
asking whether a tool was validated on patients like theirs, which the public
record cannot answer today — then the thing that answers it, vendor-
independent and traceable to source. The stake is now a concrete offer: if
that is evidence their patient-safety or policy conversations need, we shape
the first release around it.

Co-Authored-By: Claude Opus 5 <noreply@anthropic.com>
Claude-Session: https://claude.ai/code/session_01EiKQ8q6cKC5FEpVgvE6GeX
</commit_message>
<xml_diff>
--- a/slides/Presentation_for_Anthropic_Healthcare_filled.pptx
+++ b/slides/Presentation_for_Anthropic_Healthcare_filled.pptx
@@ -3929,7 +3929,7 @@
                 </a:solidFill>
                 <a:latin typeface="Century Schoolbook"/>
               </a:rPr>
-              <a:t>Where this could be useful to you.</a:t>
+              <a:t>What this could give your team.</a:t>
             </a:r>
           </a:p>
         </p:txBody>
@@ -3968,7 +3968,7 @@
                 </a:solidFill>
                 <a:latin typeface="Century Schoolbook"/>
               </a:rPr>
-              <a:t>A public, evidence-linked record of who was in the validation cohort behind every FDA-authorized AI/ML device, each value traceable to its source page — the question health systems raise in procurement, on the gap 510(k) summaries leave open.</a:t>
+              <a:t>Health systems ask whether a tool was validated on patients like theirs. The public record cannot answer that today. We are building the answer for all 1,451 authorized devices — independent of the vendor, each value traceable to its source page.</a:t>
             </a:r>
           </a:p>
         </p:txBody>
@@ -4007,7 +4007,7 @@
                 </a:solidFill>
                 <a:latin typeface="Century Schoolbook"/>
               </a:rPr>
-              <a:t>Tells us which cut to build first, and who to build it with.</a:t>
+              <a:t>If that is evidence your patient-safety or policy conversations need, tell us and we will shape the first release around it.</a:t>
             </a:r>
           </a:p>
         </p:txBody>

</xml_diff>